<commit_message>
PPTX pipeline: finish Slidev→editable PowerPoint converter
- convert_slidev.py: LAYOUT_MAP registry (Slidev layout → PPTX spec) + per-slide
  `pptx:` override; handle current deck — contained images for content-img-*,
  content-two-images, team grid (group photo + name bullets), deploy/advantage
  cards → bullets, hw-grid → bullets, bespoke <Component/> → whole-slide image
- build_deck.py: two_images + slide_image builders; image border toggle; logos
  scaled down and centred
- build_template.py: build from python-pptx default template (drop pandoc);
  top-anchored bodies (no title overlap); single uniform BODY_SZ across all
  content layouts (no per-slide autofit); fix output/logo paths
- regenerate molgenis-template-STARTER.pptx; document mapping in PPTX_PIPELINE.md

Co-Authored-By: Claude Opus 4.8 (1M context) <noreply@anthropic.com>
</commit_message>
<xml_diff>
--- a/molgenis-template-STARTER.pptx
+++ b/molgenis-template-STARTER.pptx
@@ -4,11 +4,8 @@
   <p:sldMasterIdLst>
     <p:sldMasterId id="2147483648" r:id="rId1"/>
   </p:sldMasterIdLst>
-  <p:notesMasterIdLst>
-    <p:notesMasterId r:id="rId6"/>
-  </p:notesMasterIdLst>
   <p:sldIdLst/>
-  <p:sldSz cx="9144000" cy="5143500" type="screen16x9"/>
+  <p:sldSz cx="9144000" cy="6858000" type="screen4x3"/>
   <p:notesSz cx="6858000" cy="9144000"/>
   <p:defaultTextStyle>
     <a:defPPr>
@@ -105,372 +102,7 @@
       </a:defRPr>
     </a:lvl9pPr>
   </p:defaultTextStyle>
-  <p:extLst>
-    <p:ext uri="{EFAFB233-063F-42B5-8137-9DF3F51BA10A}">
-      <p15:sldGuideLst xmlns:p15="http://schemas.microsoft.com/office/powerpoint/2012/main">
-        <p15:guide id="1" orient="horz" pos="1620" userDrawn="1">
-          <p15:clr>
-            <a:srgbClr val="A4A3A4"/>
-          </p15:clr>
-        </p15:guide>
-        <p15:guide id="2" pos="2880" userDrawn="1">
-          <p15:clr>
-            <a:srgbClr val="A4A3A4"/>
-          </p15:clr>
-        </p15:guide>
-      </p15:sldGuideLst>
-    </p:ext>
-  </p:extLst>
 </p:presentation>
-</file>
-
-<file path=ppt/notesMasters/notesMaster1.xml><?xml version="1.0" encoding="utf-8"?>
-<p:notesMaster xmlns:a="http://schemas.openxmlformats.org/drawingml/2006/main" xmlns:r="http://schemas.openxmlformats.org/officeDocument/2006/relationships" xmlns:p="http://schemas.openxmlformats.org/presentationml/2006/main">
-  <p:cSld>
-    <p:bg>
-      <p:bgRef idx="1001">
-        <a:schemeClr val="bg1"/>
-      </p:bgRef>
-    </p:bg>
-    <p:spTree>
-      <p:nvGrpSpPr>
-        <p:cNvPr id="1" name=""/>
-        <p:cNvGrpSpPr/>
-        <p:nvPr/>
-      </p:nvGrpSpPr>
-      <p:grpSpPr>
-        <a:xfrm>
-          <a:off x="0" y="0"/>
-          <a:ext cx="0" cy="0"/>
-          <a:chOff x="0" y="0"/>
-          <a:chExt cx="0" cy="0"/>
-        </a:xfrm>
-      </p:grpSpPr>
-      <p:sp>
-        <p:nvSpPr>
-          <p:cNvPr id="2" name="Header Placeholder 1"/>
-          <p:cNvSpPr>
-            <a:spLocks noGrp="1"/>
-          </p:cNvSpPr>
-          <p:nvPr>
-            <p:ph type="hdr" sz="quarter"/>
-          </p:nvPr>
-        </p:nvSpPr>
-        <p:spPr>
-          <a:xfrm>
-            <a:off x="0" y="0"/>
-            <a:ext cx="2971800" cy="458788"/>
-          </a:xfrm>
-          <a:prstGeom prst="rect">
-            <a:avLst/>
-          </a:prstGeom>
-        </p:spPr>
-        <p:txBody>
-          <a:bodyPr vert="horz" lIns="91440" tIns="45720" rIns="91440" bIns="45720" rtlCol="0"/>
-          <a:lstStyle>
-            <a:lvl1pPr algn="l">
-              <a:defRPr sz="1200"/>
-            </a:lvl1pPr>
-          </a:lstStyle>
-          <a:p>
-            <a:endParaRPr lang="en-US"/>
-          </a:p>
-        </p:txBody>
-      </p:sp>
-      <p:sp>
-        <p:nvSpPr>
-          <p:cNvPr id="3" name="Date Placeholder 2"/>
-          <p:cNvSpPr>
-            <a:spLocks noGrp="1"/>
-          </p:cNvSpPr>
-          <p:nvPr>
-            <p:ph type="dt" idx="1"/>
-          </p:nvPr>
-        </p:nvSpPr>
-        <p:spPr>
-          <a:xfrm>
-            <a:off x="3884613" y="0"/>
-            <a:ext cx="2971800" cy="458788"/>
-          </a:xfrm>
-          <a:prstGeom prst="rect">
-            <a:avLst/>
-          </a:prstGeom>
-        </p:spPr>
-        <p:txBody>
-          <a:bodyPr vert="horz" lIns="91440" tIns="45720" rIns="91440" bIns="45720" rtlCol="0"/>
-          <a:lstStyle>
-            <a:lvl1pPr algn="r">
-              <a:defRPr sz="1200"/>
-            </a:lvl1pPr>
-          </a:lstStyle>
-          <a:p>
-            <a:fld id="{0F9C1CCF-B725-44A7-AA57-5E433BD85C9F}" type="datetimeFigureOut">
-              <a:rPr lang="en-US" smtClean="0"/>
-              <a:t>1/2/22</a:t>
-            </a:fld>
-            <a:endParaRPr lang="en-US"/>
-          </a:p>
-        </p:txBody>
-      </p:sp>
-      <p:sp>
-        <p:nvSpPr>
-          <p:cNvPr id="4" name="Slide Image Placeholder 3"/>
-          <p:cNvSpPr>
-            <a:spLocks noGrp="1" noRot="1" noChangeAspect="1"/>
-          </p:cNvSpPr>
-          <p:nvPr>
-            <p:ph type="sldImg" idx="2"/>
-          </p:nvPr>
-        </p:nvSpPr>
-        <p:spPr>
-          <a:xfrm>
-            <a:off x="685800" y="1143000"/>
-            <a:ext cx="5486400" cy="3086100"/>
-          </a:xfrm>
-          <a:prstGeom prst="rect">
-            <a:avLst/>
-          </a:prstGeom>
-          <a:noFill/>
-          <a:ln w="12700">
-            <a:solidFill>
-              <a:prstClr val="black"/>
-            </a:solidFill>
-          </a:ln>
-        </p:spPr>
-        <p:txBody>
-          <a:bodyPr vert="horz" lIns="91440" tIns="45720" rIns="91440" bIns="45720" rtlCol="0" anchor="ctr"/>
-          <a:lstStyle/>
-          <a:p>
-            <a:endParaRPr lang="en-US"/>
-          </a:p>
-        </p:txBody>
-      </p:sp>
-      <p:sp>
-        <p:nvSpPr>
-          <p:cNvPr id="5" name="Notes Placeholder 4"/>
-          <p:cNvSpPr>
-            <a:spLocks noGrp="1"/>
-          </p:cNvSpPr>
-          <p:nvPr>
-            <p:ph type="body" sz="quarter" idx="3"/>
-          </p:nvPr>
-        </p:nvSpPr>
-        <p:spPr>
-          <a:xfrm>
-            <a:off x="685800" y="4400550"/>
-            <a:ext cx="5486400" cy="3600450"/>
-          </a:xfrm>
-          <a:prstGeom prst="rect">
-            <a:avLst/>
-          </a:prstGeom>
-        </p:spPr>
-        <p:txBody>
-          <a:bodyPr vert="horz" lIns="91440" tIns="45720" rIns="91440" bIns="45720" rtlCol="0"/>
-          <a:lstStyle/>
-          <a:p>
-            <a:pPr lvl="0"/>
-            <a:r>
-              <a:rPr lang="en-US"/>
-              <a:t>Click to edit Master text styles</a:t>
-            </a:r>
-          </a:p>
-          <a:p>
-            <a:pPr lvl="1"/>
-            <a:r>
-              <a:rPr lang="en-US"/>
-              <a:t>Second level</a:t>
-            </a:r>
-          </a:p>
-          <a:p>
-            <a:pPr lvl="2"/>
-            <a:r>
-              <a:rPr lang="en-US"/>
-              <a:t>Third level</a:t>
-            </a:r>
-          </a:p>
-          <a:p>
-            <a:pPr lvl="3"/>
-            <a:r>
-              <a:rPr lang="en-US"/>
-              <a:t>Fourth level</a:t>
-            </a:r>
-          </a:p>
-          <a:p>
-            <a:pPr lvl="4"/>
-            <a:r>
-              <a:rPr lang="en-US"/>
-              <a:t>Fifth level</a:t>
-            </a:r>
-          </a:p>
-        </p:txBody>
-      </p:sp>
-      <p:sp>
-        <p:nvSpPr>
-          <p:cNvPr id="6" name="Footer Placeholder 5"/>
-          <p:cNvSpPr>
-            <a:spLocks noGrp="1"/>
-          </p:cNvSpPr>
-          <p:nvPr>
-            <p:ph type="ftr" sz="quarter" idx="4"/>
-          </p:nvPr>
-        </p:nvSpPr>
-        <p:spPr>
-          <a:xfrm>
-            <a:off x="0" y="8685213"/>
-            <a:ext cx="2971800" cy="458787"/>
-          </a:xfrm>
-          <a:prstGeom prst="rect">
-            <a:avLst/>
-          </a:prstGeom>
-        </p:spPr>
-        <p:txBody>
-          <a:bodyPr vert="horz" lIns="91440" tIns="45720" rIns="91440" bIns="45720" rtlCol="0" anchor="b"/>
-          <a:lstStyle>
-            <a:lvl1pPr algn="l">
-              <a:defRPr sz="1200"/>
-            </a:lvl1pPr>
-          </a:lstStyle>
-          <a:p>
-            <a:endParaRPr lang="en-US"/>
-          </a:p>
-        </p:txBody>
-      </p:sp>
-      <p:sp>
-        <p:nvSpPr>
-          <p:cNvPr id="7" name="Slide Number Placeholder 6"/>
-          <p:cNvSpPr>
-            <a:spLocks noGrp="1"/>
-          </p:cNvSpPr>
-          <p:nvPr>
-            <p:ph type="sldNum" sz="quarter" idx="5"/>
-          </p:nvPr>
-        </p:nvSpPr>
-        <p:spPr>
-          <a:xfrm>
-            <a:off x="3884613" y="8685213"/>
-            <a:ext cx="2971800" cy="458787"/>
-          </a:xfrm>
-          <a:prstGeom prst="rect">
-            <a:avLst/>
-          </a:prstGeom>
-        </p:spPr>
-        <p:txBody>
-          <a:bodyPr vert="horz" lIns="91440" tIns="45720" rIns="91440" bIns="45720" rtlCol="0" anchor="b"/>
-          <a:lstStyle>
-            <a:lvl1pPr algn="r">
-              <a:defRPr sz="1200"/>
-            </a:lvl1pPr>
-          </a:lstStyle>
-          <a:p>
-            <a:fld id="{18BDFEC3-8487-43E8-A154-7C12CBC1FFF2}" type="slidenum">
-              <a:rPr lang="en-US" smtClean="0"/>
-              <a:t>‹#›</a:t>
-            </a:fld>
-            <a:endParaRPr lang="en-US"/>
-          </a:p>
-        </p:txBody>
-      </p:sp>
-    </p:spTree>
-    <p:extLst>
-      <p:ext uri="{BB962C8B-B14F-4D97-AF65-F5344CB8AC3E}">
-        <p14:creationId xmlns:p14="http://schemas.microsoft.com/office/powerpoint/2010/main" val="3782709779"/>
-      </p:ext>
-    </p:extLst>
-  </p:cSld>
-  <p:clrMap bg1="lt1" tx1="dk1" bg2="lt2" tx2="dk2" accent1="accent1" accent2="accent2" accent3="accent3" accent4="accent4" accent5="accent5" accent6="accent6" hlink="hlink" folHlink="folHlink"/>
-  <p:notesStyle>
-    <a:lvl1pPr marL="0" algn="l" defTabSz="914400" rtl="0" eaLnBrk="1" latinLnBrk="0" hangingPunct="1">
-      <a:defRPr sz="1200" kern="1200">
-        <a:solidFill>
-          <a:schemeClr val="tx1"/>
-        </a:solidFill>
-        <a:latin typeface="+mn-lt"/>
-        <a:ea typeface="+mn-ea"/>
-        <a:cs typeface="+mn-cs"/>
-      </a:defRPr>
-    </a:lvl1pPr>
-    <a:lvl2pPr marL="457200" algn="l" defTabSz="914400" rtl="0" eaLnBrk="1" latinLnBrk="0" hangingPunct="1">
-      <a:defRPr sz="1200" kern="1200">
-        <a:solidFill>
-          <a:schemeClr val="tx1"/>
-        </a:solidFill>
-        <a:latin typeface="+mn-lt"/>
-        <a:ea typeface="+mn-ea"/>
-        <a:cs typeface="+mn-cs"/>
-      </a:defRPr>
-    </a:lvl2pPr>
-    <a:lvl3pPr marL="914400" algn="l" defTabSz="914400" rtl="0" eaLnBrk="1" latinLnBrk="0" hangingPunct="1">
-      <a:defRPr sz="1200" kern="1200">
-        <a:solidFill>
-          <a:schemeClr val="tx1"/>
-        </a:solidFill>
-        <a:latin typeface="+mn-lt"/>
-        <a:ea typeface="+mn-ea"/>
-        <a:cs typeface="+mn-cs"/>
-      </a:defRPr>
-    </a:lvl3pPr>
-    <a:lvl4pPr marL="1371600" algn="l" defTabSz="914400" rtl="0" eaLnBrk="1" latinLnBrk="0" hangingPunct="1">
-      <a:defRPr sz="1200" kern="1200">
-        <a:solidFill>
-          <a:schemeClr val="tx1"/>
-        </a:solidFill>
-        <a:latin typeface="+mn-lt"/>
-        <a:ea typeface="+mn-ea"/>
-        <a:cs typeface="+mn-cs"/>
-      </a:defRPr>
-    </a:lvl4pPr>
-    <a:lvl5pPr marL="1828800" algn="l" defTabSz="914400" rtl="0" eaLnBrk="1" latinLnBrk="0" hangingPunct="1">
-      <a:defRPr sz="1200" kern="1200">
-        <a:solidFill>
-          <a:schemeClr val="tx1"/>
-        </a:solidFill>
-        <a:latin typeface="+mn-lt"/>
-        <a:ea typeface="+mn-ea"/>
-        <a:cs typeface="+mn-cs"/>
-      </a:defRPr>
-    </a:lvl5pPr>
-    <a:lvl6pPr marL="2286000" algn="l" defTabSz="914400" rtl="0" eaLnBrk="1" latinLnBrk="0" hangingPunct="1">
-      <a:defRPr sz="1200" kern="1200">
-        <a:solidFill>
-          <a:schemeClr val="tx1"/>
-        </a:solidFill>
-        <a:latin typeface="+mn-lt"/>
-        <a:ea typeface="+mn-ea"/>
-        <a:cs typeface="+mn-cs"/>
-      </a:defRPr>
-    </a:lvl6pPr>
-    <a:lvl7pPr marL="2743200" algn="l" defTabSz="914400" rtl="0" eaLnBrk="1" latinLnBrk="0" hangingPunct="1">
-      <a:defRPr sz="1200" kern="1200">
-        <a:solidFill>
-          <a:schemeClr val="tx1"/>
-        </a:solidFill>
-        <a:latin typeface="+mn-lt"/>
-        <a:ea typeface="+mn-ea"/>
-        <a:cs typeface="+mn-cs"/>
-      </a:defRPr>
-    </a:lvl7pPr>
-    <a:lvl8pPr marL="3200400" algn="l" defTabSz="914400" rtl="0" eaLnBrk="1" latinLnBrk="0" hangingPunct="1">
-      <a:defRPr sz="1200" kern="1200">
-        <a:solidFill>
-          <a:schemeClr val="tx1"/>
-        </a:solidFill>
-        <a:latin typeface="+mn-lt"/>
-        <a:ea typeface="+mn-ea"/>
-        <a:cs typeface="+mn-cs"/>
-      </a:defRPr>
-    </a:lvl8pPr>
-    <a:lvl9pPr marL="3657600" algn="l" defTabSz="914400" rtl="0" eaLnBrk="1" latinLnBrk="0" hangingPunct="1">
-      <a:defRPr sz="1200" kern="1200">
-        <a:solidFill>
-          <a:schemeClr val="tx1"/>
-        </a:solidFill>
-        <a:latin typeface="+mn-lt"/>
-        <a:ea typeface="+mn-ea"/>
-        <a:cs typeface="+mn-cs"/>
-      </a:defRPr>
-    </a:lvl9pPr>
-  </p:notesStyle>
-</p:notesMaster>
 </file>
 
 <file path=ppt/slideLayouts/slideLayout1.xml><?xml version="1.0" encoding="utf-8"?>
@@ -532,9 +164,10 @@
           </a:lstStyle>
           <a:p>
             <a:r>
-              <a:rPr lang="en-US"/>
+              <a:rPr lang="en-US" smtClean="0"/>
               <a:t>Click to edit Master title style</a:t>
             </a:r>
+            <a:endParaRPr lang="en-US"/>
           </a:p>
         </p:txBody>
       </p:sp>
@@ -553,9 +186,9 @@
           <a:bodyPr/>
           <a:lstStyle/>
           <a:p>
-            <a:fld id="{241EB5C9-1307-BA42-ABA2-0BC069CD8E7F}" type="datetimeFigureOut">
-              <a:rPr lang="en-US" smtClean="0"/>
-              <a:t>1/2/22</a:t>
+            <a:fld id="{5BCAD085-E8A6-8845-BD4E-CB4CCA059FC4}" type="datetimeFigureOut">
+              <a:rPr lang="en-US" smtClean="0"/>
+              <a:t>1/27/13</a:t>
             </a:fld>
             <a:endParaRPr lang="en-US"/>
           </a:p>
@@ -595,7 +228,7 @@
           <a:bodyPr/>
           <a:lstStyle/>
           <a:p>
-            <a:fld id="{C5EF2332-01BF-834F-8236-50238282D533}" type="slidenum">
+            <a:fld id="{C1FF6DA9-008F-8B48-92A6-B652298478BF}" type="slidenum">
               <a:rPr lang="en-US" smtClean="0"/>
               <a:t>‹#›</a:t>
             </a:fld>
@@ -635,7 +268,7 @@
     </p:spTree>
     <p:extLst>
       <p:ext uri="{BB962C8B-B14F-4D97-AF65-F5344CB8AC3E}">
-        <p14:creationId xmlns:p14="http://schemas.microsoft.com/office/powerpoint/2010/main" val="1444357513"/>
+        <p14:creationId xmlns:p14="http://schemas.microsoft.com/office/powerpoint/2010/main" val="3168075583"/>
       </p:ext>
     </p:extLst>
   </p:cSld>
@@ -705,9 +338,10 @@
           </a:lstStyle>
           <a:p>
             <a:r>
-              <a:rPr lang="en-US"/>
+              <a:rPr lang="en-US" smtClean="0"/>
               <a:t>Click to edit Master title style</a:t>
             </a:r>
+            <a:endParaRPr lang="en-US"/>
           </a:p>
         </p:txBody>
       </p:sp>
@@ -728,7 +362,7 @@
           </a:xfrm>
         </p:spPr>
         <p:txBody>
-          <a:bodyPr/>
+          <a:bodyPr anchor="t"/>
           <a:lstStyle>
             <a:lvl1pPr marL="228600" indent="-228600">
               <a:spcAft>
@@ -736,7 +370,7 @@
               </a:spcAft>
               <a:buFont typeface="Arial"/>
               <a:buChar char="•"/>
-              <a:defRPr sz="1800">
+              <a:defRPr sz="1400">
                 <a:solidFill>
                   <a:srgbClr val="000000"/>
                 </a:solidFill>
@@ -746,7 +380,7 @@
             <a:lvl2pPr marL="685800" indent="-228600">
               <a:buFont typeface="Arial"/>
               <a:buChar char="•"/>
-              <a:defRPr sz="1600">
+              <a:defRPr sz="1200">
                 <a:solidFill>
                   <a:srgbClr val="000000"/>
                 </a:solidFill>
@@ -757,37 +391,38 @@
           <a:p>
             <a:pPr lvl="0"/>
             <a:r>
-              <a:rPr lang="en-US"/>
+              <a:rPr lang="en-US" smtClean="0"/>
               <a:t>Click to edit Master text styles</a:t>
             </a:r>
           </a:p>
           <a:p>
             <a:pPr lvl="1"/>
             <a:r>
-              <a:rPr lang="en-US"/>
+              <a:rPr lang="en-US" smtClean="0"/>
               <a:t>Second level</a:t>
             </a:r>
           </a:p>
           <a:p>
             <a:pPr lvl="2"/>
             <a:r>
-              <a:rPr lang="en-US"/>
+              <a:rPr lang="en-US" smtClean="0"/>
               <a:t>Third level</a:t>
             </a:r>
           </a:p>
           <a:p>
             <a:pPr lvl="3"/>
             <a:r>
-              <a:rPr lang="en-US"/>
+              <a:rPr lang="en-US" smtClean="0"/>
               <a:t>Fourth level</a:t>
             </a:r>
           </a:p>
           <a:p>
             <a:pPr lvl="4"/>
             <a:r>
-              <a:rPr lang="en-US"/>
+              <a:rPr lang="en-US" smtClean="0"/>
               <a:t>Fifth level</a:t>
             </a:r>
+            <a:endParaRPr lang="en-US"/>
           </a:p>
         </p:txBody>
       </p:sp>
@@ -806,9 +441,9 @@
           <a:bodyPr/>
           <a:lstStyle/>
           <a:p>
-            <a:fld id="{241EB5C9-1307-BA42-ABA2-0BC069CD8E7F}" type="datetimeFigureOut">
-              <a:rPr lang="en-US" smtClean="0"/>
-              <a:t>1/2/22</a:t>
+            <a:fld id="{5BCAD085-E8A6-8845-BD4E-CB4CCA059FC4}" type="datetimeFigureOut">
+              <a:rPr lang="en-US" smtClean="0"/>
+              <a:t>1/27/13</a:t>
             </a:fld>
             <a:endParaRPr lang="en-US"/>
           </a:p>
@@ -848,7 +483,7 @@
           <a:bodyPr/>
           <a:lstStyle/>
           <a:p>
-            <a:fld id="{C5EF2332-01BF-834F-8236-50238282D533}" type="slidenum">
+            <a:fld id="{C1FF6DA9-008F-8B48-92A6-B652298478BF}" type="slidenum">
               <a:rPr lang="en-US" smtClean="0"/>
               <a:t>‹#›</a:t>
             </a:fld>
@@ -888,7 +523,7 @@
     </p:spTree>
     <p:extLst>
       <p:ext uri="{BB962C8B-B14F-4D97-AF65-F5344CB8AC3E}">
-        <p14:creationId xmlns:p14="http://schemas.microsoft.com/office/powerpoint/2010/main" val="338346009"/>
+        <p14:creationId xmlns:p14="http://schemas.microsoft.com/office/powerpoint/2010/main" val="2614314258"/>
       </p:ext>
     </p:extLst>
   </p:cSld>
@@ -958,9 +593,10 @@
           </a:lstStyle>
           <a:p>
             <a:r>
-              <a:rPr lang="en-US"/>
+              <a:rPr lang="en-US" smtClean="0"/>
               <a:t>Click to edit Master title style</a:t>
             </a:r>
+            <a:endParaRPr lang="en-US"/>
           </a:p>
         </p:txBody>
       </p:sp>
@@ -984,67 +620,68 @@
           <a:bodyPr/>
           <a:lstStyle>
             <a:lvl1pPr>
-              <a:defRPr sz="2100"/>
+              <a:defRPr sz="2800"/>
             </a:lvl1pPr>
             <a:lvl2pPr>
-              <a:defRPr sz="1800"/>
+              <a:defRPr sz="2400"/>
             </a:lvl2pPr>
             <a:lvl3pPr>
-              <a:defRPr sz="1500"/>
+              <a:defRPr sz="2000"/>
             </a:lvl3pPr>
             <a:lvl4pPr>
-              <a:defRPr sz="1350"/>
+              <a:defRPr sz="1800"/>
             </a:lvl4pPr>
             <a:lvl5pPr>
-              <a:defRPr sz="1350"/>
+              <a:defRPr sz="1800"/>
             </a:lvl5pPr>
             <a:lvl6pPr>
-              <a:defRPr sz="1350"/>
+              <a:defRPr sz="1800"/>
             </a:lvl6pPr>
             <a:lvl7pPr>
-              <a:defRPr sz="1350"/>
+              <a:defRPr sz="1800"/>
             </a:lvl7pPr>
             <a:lvl8pPr>
-              <a:defRPr sz="1350"/>
+              <a:defRPr sz="1800"/>
             </a:lvl8pPr>
             <a:lvl9pPr>
-              <a:defRPr sz="1350"/>
+              <a:defRPr sz="1800"/>
             </a:lvl9pPr>
           </a:lstStyle>
           <a:p>
             <a:pPr lvl="0"/>
             <a:r>
-              <a:rPr lang="en-US"/>
+              <a:rPr lang="en-US" smtClean="0"/>
               <a:t>Click to edit Master text styles</a:t>
             </a:r>
           </a:p>
           <a:p>
             <a:pPr lvl="1"/>
             <a:r>
-              <a:rPr lang="en-US"/>
+              <a:rPr lang="en-US" smtClean="0"/>
               <a:t>Second level</a:t>
             </a:r>
           </a:p>
           <a:p>
             <a:pPr lvl="2"/>
             <a:r>
-              <a:rPr lang="en-US"/>
+              <a:rPr lang="en-US" smtClean="0"/>
               <a:t>Third level</a:t>
             </a:r>
           </a:p>
           <a:p>
             <a:pPr lvl="3"/>
             <a:r>
-              <a:rPr lang="en-US"/>
+              <a:rPr lang="en-US" smtClean="0"/>
               <a:t>Fourth level</a:t>
             </a:r>
           </a:p>
           <a:p>
             <a:pPr lvl="4"/>
             <a:r>
-              <a:rPr lang="en-US"/>
+              <a:rPr lang="en-US" smtClean="0"/>
               <a:t>Fifth level</a:t>
             </a:r>
+            <a:endParaRPr lang="en-US"/>
           </a:p>
         </p:txBody>
       </p:sp>
@@ -1065,7 +702,7 @@
           </a:xfrm>
         </p:spPr>
         <p:txBody>
-          <a:bodyPr/>
+          <a:bodyPr anchor="t"/>
           <a:lstStyle>
             <a:lvl1pPr marL="228600" indent="-228600">
               <a:spcAft>
@@ -1073,7 +710,7 @@
               </a:spcAft>
               <a:buFont typeface="Arial"/>
               <a:buChar char="•"/>
-              <a:defRPr sz="1600">
+              <a:defRPr sz="1400">
                 <a:solidFill>
                   <a:srgbClr val="000000"/>
                 </a:solidFill>
@@ -1083,7 +720,7 @@
             <a:lvl2pPr marL="685800" indent="-228600">
               <a:buFont typeface="Arial"/>
               <a:buChar char="•"/>
-              <a:defRPr sz="1400">
+              <a:defRPr sz="1200">
                 <a:solidFill>
                   <a:srgbClr val="000000"/>
                 </a:solidFill>
@@ -1091,61 +728,62 @@
               </a:defRPr>
             </a:lvl2pPr>
             <a:lvl3pPr>
-              <a:defRPr sz="1500"/>
+              <a:defRPr sz="2000"/>
             </a:lvl3pPr>
             <a:lvl4pPr>
-              <a:defRPr sz="1350"/>
+              <a:defRPr sz="1800"/>
             </a:lvl4pPr>
             <a:lvl5pPr>
-              <a:defRPr sz="1350"/>
+              <a:defRPr sz="1800"/>
             </a:lvl5pPr>
             <a:lvl6pPr>
-              <a:defRPr sz="1350"/>
+              <a:defRPr sz="1800"/>
             </a:lvl6pPr>
             <a:lvl7pPr>
-              <a:defRPr sz="1350"/>
+              <a:defRPr sz="1800"/>
             </a:lvl7pPr>
             <a:lvl8pPr>
-              <a:defRPr sz="1350"/>
+              <a:defRPr sz="1800"/>
             </a:lvl8pPr>
             <a:lvl9pPr>
-              <a:defRPr sz="1350"/>
+              <a:defRPr sz="1800"/>
             </a:lvl9pPr>
           </a:lstStyle>
           <a:p>
             <a:pPr lvl="0"/>
             <a:r>
-              <a:rPr lang="en-US"/>
+              <a:rPr lang="en-US" smtClean="0"/>
               <a:t>Click to edit Master text styles</a:t>
             </a:r>
           </a:p>
           <a:p>
             <a:pPr lvl="1"/>
             <a:r>
-              <a:rPr lang="en-US"/>
+              <a:rPr lang="en-US" smtClean="0"/>
               <a:t>Second level</a:t>
             </a:r>
           </a:p>
           <a:p>
             <a:pPr lvl="2"/>
             <a:r>
-              <a:rPr lang="en-US"/>
+              <a:rPr lang="en-US" smtClean="0"/>
               <a:t>Third level</a:t>
             </a:r>
           </a:p>
           <a:p>
             <a:pPr lvl="3"/>
             <a:r>
-              <a:rPr lang="en-US"/>
+              <a:rPr lang="en-US" smtClean="0"/>
               <a:t>Fourth level</a:t>
             </a:r>
           </a:p>
           <a:p>
             <a:pPr lvl="4"/>
             <a:r>
-              <a:rPr lang="en-US"/>
+              <a:rPr lang="en-US" smtClean="0"/>
               <a:t>Fifth level</a:t>
             </a:r>
+            <a:endParaRPr lang="en-US"/>
           </a:p>
         </p:txBody>
       </p:sp>
@@ -1164,9 +802,9 @@
           <a:bodyPr/>
           <a:lstStyle/>
           <a:p>
-            <a:fld id="{241EB5C9-1307-BA42-ABA2-0BC069CD8E7F}" type="datetimeFigureOut">
-              <a:rPr lang="en-US" smtClean="0"/>
-              <a:t>1/2/22</a:t>
+            <a:fld id="{5BCAD085-E8A6-8845-BD4E-CB4CCA059FC4}" type="datetimeFigureOut">
+              <a:rPr lang="en-US" smtClean="0"/>
+              <a:t>1/27/13</a:t>
             </a:fld>
             <a:endParaRPr lang="en-US"/>
           </a:p>
@@ -1206,7 +844,7 @@
           <a:bodyPr/>
           <a:lstStyle/>
           <a:p>
-            <a:fld id="{C5EF2332-01BF-834F-8236-50238282D533}" type="slidenum">
+            <a:fld id="{C1FF6DA9-008F-8B48-92A6-B652298478BF}" type="slidenum">
               <a:rPr lang="en-US" smtClean="0"/>
               <a:t>‹#›</a:t>
             </a:fld>
@@ -1246,7 +884,7 @@
     </p:spTree>
     <p:extLst>
       <p:ext uri="{BB962C8B-B14F-4D97-AF65-F5344CB8AC3E}">
-        <p14:creationId xmlns:p14="http://schemas.microsoft.com/office/powerpoint/2010/main" val="2619886245"/>
+        <p14:creationId xmlns:p14="http://schemas.microsoft.com/office/powerpoint/2010/main" val="2782244947"/>
       </p:ext>
     </p:extLst>
   </p:cSld>
@@ -1316,9 +954,10 @@
           </a:lstStyle>
           <a:p>
             <a:r>
-              <a:rPr lang="en-US"/>
+              <a:rPr lang="en-US" smtClean="0"/>
               <a:t>Click to edit Master title style</a:t>
             </a:r>
+            <a:endParaRPr lang="en-US"/>
           </a:p>
         </p:txBody>
       </p:sp>
@@ -1339,7 +978,7 @@
           </a:xfrm>
         </p:spPr>
         <p:txBody>
-          <a:bodyPr anchor="b"/>
+          <a:bodyPr anchor="t"/>
           <a:lstStyle>
             <a:lvl1pPr marL="228600" indent="-228600">
               <a:spcAft>
@@ -1347,7 +986,7 @@
               </a:spcAft>
               <a:buFont typeface="Arial"/>
               <a:buChar char="•"/>
-              <a:defRPr sz="1600">
+              <a:defRPr sz="1400">
                 <a:solidFill>
                   <a:srgbClr val="000000"/>
                 </a:solidFill>
@@ -1357,46 +996,46 @@
             <a:lvl2pPr marL="685800" indent="-228600">
               <a:buFont typeface="Arial"/>
               <a:buChar char="•"/>
-              <a:defRPr sz="1400">
+              <a:defRPr sz="1200">
                 <a:solidFill>
                   <a:srgbClr val="000000"/>
                 </a:solidFill>
                 <a:latin typeface="Nunito"/>
               </a:defRPr>
             </a:lvl2pPr>
-            <a:lvl3pPr marL="685800" indent="0">
-              <a:buNone/>
-              <a:defRPr sz="1350" b="1"/>
+            <a:lvl3pPr marL="914400" indent="0">
+              <a:buNone/>
+              <a:defRPr sz="1800" b="1"/>
             </a:lvl3pPr>
-            <a:lvl4pPr marL="1028700" indent="0">
-              <a:buNone/>
-              <a:defRPr sz="1200" b="1"/>
+            <a:lvl4pPr marL="1371600" indent="0">
+              <a:buNone/>
+              <a:defRPr sz="1600" b="1"/>
             </a:lvl4pPr>
-            <a:lvl5pPr marL="1371600" indent="0">
-              <a:buNone/>
-              <a:defRPr sz="1200" b="1"/>
+            <a:lvl5pPr marL="1828800" indent="0">
+              <a:buNone/>
+              <a:defRPr sz="1600" b="1"/>
             </a:lvl5pPr>
-            <a:lvl6pPr marL="1714500" indent="0">
-              <a:buNone/>
-              <a:defRPr sz="1200" b="1"/>
+            <a:lvl6pPr marL="2286000" indent="0">
+              <a:buNone/>
+              <a:defRPr sz="1600" b="1"/>
             </a:lvl6pPr>
-            <a:lvl7pPr marL="2057400" indent="0">
-              <a:buNone/>
-              <a:defRPr sz="1200" b="1"/>
+            <a:lvl7pPr marL="2743200" indent="0">
+              <a:buNone/>
+              <a:defRPr sz="1600" b="1"/>
             </a:lvl7pPr>
-            <a:lvl8pPr marL="2400300" indent="0">
-              <a:buNone/>
-              <a:defRPr sz="1200" b="1"/>
+            <a:lvl8pPr marL="3200400" indent="0">
+              <a:buNone/>
+              <a:defRPr sz="1600" b="1"/>
             </a:lvl8pPr>
-            <a:lvl9pPr marL="2743200" indent="0">
-              <a:buNone/>
-              <a:defRPr sz="1200" b="1"/>
+            <a:lvl9pPr marL="3657600" indent="0">
+              <a:buNone/>
+              <a:defRPr sz="1600" b="1"/>
             </a:lvl9pPr>
           </a:lstStyle>
           <a:p>
             <a:pPr lvl="0"/>
             <a:r>
-              <a:rPr lang="en-US"/>
+              <a:rPr lang="en-US" smtClean="0"/>
               <a:t>Click to edit Master text styles</a:t>
             </a:r>
           </a:p>
@@ -1422,67 +1061,68 @@
           <a:bodyPr/>
           <a:lstStyle>
             <a:lvl1pPr>
-              <a:defRPr sz="1800"/>
+              <a:defRPr sz="2400"/>
             </a:lvl1pPr>
             <a:lvl2pPr>
-              <a:defRPr sz="1500"/>
+              <a:defRPr sz="2000"/>
             </a:lvl2pPr>
             <a:lvl3pPr>
-              <a:defRPr sz="1350"/>
+              <a:defRPr sz="1800"/>
             </a:lvl3pPr>
             <a:lvl4pPr>
-              <a:defRPr sz="1200"/>
+              <a:defRPr sz="1600"/>
             </a:lvl4pPr>
             <a:lvl5pPr>
-              <a:defRPr sz="1200"/>
+              <a:defRPr sz="1600"/>
             </a:lvl5pPr>
             <a:lvl6pPr>
-              <a:defRPr sz="1200"/>
+              <a:defRPr sz="1600"/>
             </a:lvl6pPr>
             <a:lvl7pPr>
-              <a:defRPr sz="1200"/>
+              <a:defRPr sz="1600"/>
             </a:lvl7pPr>
             <a:lvl8pPr>
-              <a:defRPr sz="1200"/>
+              <a:defRPr sz="1600"/>
             </a:lvl8pPr>
             <a:lvl9pPr>
-              <a:defRPr sz="1200"/>
+              <a:defRPr sz="1600"/>
             </a:lvl9pPr>
           </a:lstStyle>
           <a:p>
             <a:pPr lvl="0"/>
             <a:r>
-              <a:rPr lang="en-US"/>
+              <a:rPr lang="en-US" smtClean="0"/>
               <a:t>Click to edit Master text styles</a:t>
             </a:r>
           </a:p>
           <a:p>
             <a:pPr lvl="1"/>
             <a:r>
-              <a:rPr lang="en-US"/>
+              <a:rPr lang="en-US" smtClean="0"/>
               <a:t>Second level</a:t>
             </a:r>
           </a:p>
           <a:p>
             <a:pPr lvl="2"/>
             <a:r>
-              <a:rPr lang="en-US"/>
+              <a:rPr lang="en-US" smtClean="0"/>
               <a:t>Third level</a:t>
             </a:r>
           </a:p>
           <a:p>
             <a:pPr lvl="3"/>
             <a:r>
-              <a:rPr lang="en-US"/>
+              <a:rPr lang="en-US" smtClean="0"/>
               <a:t>Fourth level</a:t>
             </a:r>
           </a:p>
           <a:p>
             <a:pPr lvl="4"/>
             <a:r>
-              <a:rPr lang="en-US"/>
+              <a:rPr lang="en-US" smtClean="0"/>
               <a:t>Fifth level</a:t>
             </a:r>
+            <a:endParaRPr lang="en-US"/>
           </a:p>
         </p:txBody>
       </p:sp>
@@ -1501,9 +1141,9 @@
           <a:bodyPr/>
           <a:lstStyle/>
           <a:p>
-            <a:fld id="{241EB5C9-1307-BA42-ABA2-0BC069CD8E7F}" type="datetimeFigureOut">
-              <a:rPr lang="en-US" smtClean="0"/>
-              <a:t>1/2/22</a:t>
+            <a:fld id="{5BCAD085-E8A6-8845-BD4E-CB4CCA059FC4}" type="datetimeFigureOut">
+              <a:rPr lang="en-US" smtClean="0"/>
+              <a:t>1/27/13</a:t>
             </a:fld>
             <a:endParaRPr lang="en-US"/>
           </a:p>
@@ -1543,7 +1183,7 @@
           <a:bodyPr/>
           <a:lstStyle/>
           <a:p>
-            <a:fld id="{C5EF2332-01BF-834F-8236-50238282D533}" type="slidenum">
+            <a:fld id="{C1FF6DA9-008F-8B48-92A6-B652298478BF}" type="slidenum">
               <a:rPr lang="en-US" smtClean="0"/>
               <a:t>‹#›</a:t>
             </a:fld>
@@ -1583,7 +1223,7 @@
     </p:spTree>
     <p:extLst>
       <p:ext uri="{BB962C8B-B14F-4D97-AF65-F5344CB8AC3E}">
-        <p14:creationId xmlns:p14="http://schemas.microsoft.com/office/powerpoint/2010/main" val="2535793967"/>
+        <p14:creationId xmlns:p14="http://schemas.microsoft.com/office/powerpoint/2010/main" val="990158736"/>
       </p:ext>
     </p:extLst>
   </p:cSld>
@@ -1653,9 +1293,10 @@
           </a:lstStyle>
           <a:p>
             <a:r>
-              <a:rPr lang="en-US"/>
+              <a:rPr lang="en-US" smtClean="0"/>
               <a:t>Click to edit Master title style</a:t>
             </a:r>
+            <a:endParaRPr lang="en-US"/>
           </a:p>
         </p:txBody>
       </p:sp>
@@ -1674,9 +1315,9 @@
           <a:bodyPr/>
           <a:lstStyle/>
           <a:p>
-            <a:fld id="{241EB5C9-1307-BA42-ABA2-0BC069CD8E7F}" type="datetimeFigureOut">
-              <a:rPr lang="en-US" smtClean="0"/>
-              <a:t>1/2/22</a:t>
+            <a:fld id="{5BCAD085-E8A6-8845-BD4E-CB4CCA059FC4}" type="datetimeFigureOut">
+              <a:rPr lang="en-US" smtClean="0"/>
+              <a:t>1/27/13</a:t>
             </a:fld>
             <a:endParaRPr lang="en-US"/>
           </a:p>
@@ -1716,7 +1357,7 @@
           <a:bodyPr/>
           <a:lstStyle/>
           <a:p>
-            <a:fld id="{C5EF2332-01BF-834F-8236-50238282D533}" type="slidenum">
+            <a:fld id="{C1FF6DA9-008F-8B48-92A6-B652298478BF}" type="slidenum">
               <a:rPr lang="en-US" smtClean="0"/>
               <a:t>‹#›</a:t>
             </a:fld>
@@ -1756,7 +1397,7 @@
     </p:spTree>
     <p:extLst>
       <p:ext uri="{BB962C8B-B14F-4D97-AF65-F5344CB8AC3E}">
-        <p14:creationId xmlns:p14="http://schemas.microsoft.com/office/powerpoint/2010/main" val="3472721253"/>
+        <p14:creationId xmlns:p14="http://schemas.microsoft.com/office/powerpoint/2010/main" val="727027711"/>
       </p:ext>
     </p:extLst>
   </p:cSld>
@@ -1826,9 +1467,10 @@
           </a:lstStyle>
           <a:p>
             <a:r>
-              <a:rPr lang="en-US"/>
+              <a:rPr lang="en-US" smtClean="0"/>
               <a:t>Click to edit Master title style</a:t>
             </a:r>
+            <a:endParaRPr lang="en-US"/>
           </a:p>
         </p:txBody>
       </p:sp>
@@ -1852,67 +1494,68 @@
           <a:bodyPr/>
           <a:lstStyle>
             <a:lvl1pPr>
-              <a:defRPr sz="2400"/>
+              <a:defRPr sz="3200"/>
             </a:lvl1pPr>
             <a:lvl2pPr>
-              <a:defRPr sz="2100"/>
+              <a:defRPr sz="2800"/>
             </a:lvl2pPr>
             <a:lvl3pPr>
-              <a:defRPr sz="1800"/>
+              <a:defRPr sz="2400"/>
             </a:lvl3pPr>
             <a:lvl4pPr>
-              <a:defRPr sz="1500"/>
+              <a:defRPr sz="2000"/>
             </a:lvl4pPr>
             <a:lvl5pPr>
-              <a:defRPr sz="1500"/>
+              <a:defRPr sz="2000"/>
             </a:lvl5pPr>
             <a:lvl6pPr>
-              <a:defRPr sz="1500"/>
+              <a:defRPr sz="2000"/>
             </a:lvl6pPr>
             <a:lvl7pPr>
-              <a:defRPr sz="1500"/>
+              <a:defRPr sz="2000"/>
             </a:lvl7pPr>
             <a:lvl8pPr>
-              <a:defRPr sz="1500"/>
+              <a:defRPr sz="2000"/>
             </a:lvl8pPr>
             <a:lvl9pPr>
-              <a:defRPr sz="1500"/>
+              <a:defRPr sz="2000"/>
             </a:lvl9pPr>
           </a:lstStyle>
           <a:p>
             <a:pPr lvl="0"/>
             <a:r>
-              <a:rPr lang="en-US"/>
+              <a:rPr lang="en-US" smtClean="0"/>
               <a:t>Click to edit Master text styles</a:t>
             </a:r>
           </a:p>
           <a:p>
             <a:pPr lvl="1"/>
             <a:r>
-              <a:rPr lang="en-US"/>
+              <a:rPr lang="en-US" smtClean="0"/>
               <a:t>Second level</a:t>
             </a:r>
           </a:p>
           <a:p>
             <a:pPr lvl="2"/>
             <a:r>
-              <a:rPr lang="en-US"/>
+              <a:rPr lang="en-US" smtClean="0"/>
               <a:t>Third level</a:t>
             </a:r>
           </a:p>
           <a:p>
             <a:pPr lvl="3"/>
             <a:r>
-              <a:rPr lang="en-US"/>
+              <a:rPr lang="en-US" smtClean="0"/>
               <a:t>Fourth level</a:t>
             </a:r>
           </a:p>
           <a:p>
             <a:pPr lvl="4"/>
             <a:r>
-              <a:rPr lang="en-US"/>
+              <a:rPr lang="en-US" smtClean="0"/>
               <a:t>Fifth level</a:t>
             </a:r>
+            <a:endParaRPr lang="en-US"/>
           </a:p>
         </p:txBody>
       </p:sp>
@@ -1933,7 +1576,7 @@
           </a:xfrm>
         </p:spPr>
         <p:txBody>
-          <a:bodyPr/>
+          <a:bodyPr anchor="t"/>
           <a:lstStyle>
             <a:lvl1pPr marL="228600" indent="-228600">
               <a:spcAft>
@@ -1941,7 +1584,7 @@
               </a:spcAft>
               <a:buFont typeface="Arial"/>
               <a:buChar char="•"/>
-              <a:defRPr sz="1600">
+              <a:defRPr sz="1400">
                 <a:solidFill>
                   <a:srgbClr val="000000"/>
                 </a:solidFill>
@@ -1951,46 +1594,46 @@
             <a:lvl2pPr marL="685800" indent="-228600">
               <a:buFont typeface="Arial"/>
               <a:buChar char="•"/>
-              <a:defRPr sz="1400">
+              <a:defRPr sz="1200">
                 <a:solidFill>
                   <a:srgbClr val="000000"/>
                 </a:solidFill>
                 <a:latin typeface="Nunito"/>
               </a:defRPr>
             </a:lvl2pPr>
-            <a:lvl3pPr marL="685800" indent="0">
-              <a:buNone/>
-              <a:defRPr sz="750"/>
+            <a:lvl3pPr marL="914400" indent="0">
+              <a:buNone/>
+              <a:defRPr sz="1000"/>
             </a:lvl3pPr>
-            <a:lvl4pPr marL="1028700" indent="0">
-              <a:buNone/>
-              <a:defRPr sz="675"/>
+            <a:lvl4pPr marL="1371600" indent="0">
+              <a:buNone/>
+              <a:defRPr sz="900"/>
             </a:lvl4pPr>
-            <a:lvl5pPr marL="1371600" indent="0">
-              <a:buNone/>
-              <a:defRPr sz="675"/>
+            <a:lvl5pPr marL="1828800" indent="0">
+              <a:buNone/>
+              <a:defRPr sz="900"/>
             </a:lvl5pPr>
-            <a:lvl6pPr marL="1714500" indent="0">
-              <a:buNone/>
-              <a:defRPr sz="675"/>
+            <a:lvl6pPr marL="2286000" indent="0">
+              <a:buNone/>
+              <a:defRPr sz="900"/>
             </a:lvl6pPr>
-            <a:lvl7pPr marL="2057400" indent="0">
-              <a:buNone/>
-              <a:defRPr sz="675"/>
+            <a:lvl7pPr marL="2743200" indent="0">
+              <a:buNone/>
+              <a:defRPr sz="900"/>
             </a:lvl7pPr>
-            <a:lvl8pPr marL="2400300" indent="0">
-              <a:buNone/>
-              <a:defRPr sz="675"/>
+            <a:lvl8pPr marL="3200400" indent="0">
+              <a:buNone/>
+              <a:defRPr sz="900"/>
             </a:lvl8pPr>
-            <a:lvl9pPr marL="2743200" indent="0">
-              <a:buNone/>
-              <a:defRPr sz="675"/>
+            <a:lvl9pPr marL="3657600" indent="0">
+              <a:buNone/>
+              <a:defRPr sz="900"/>
             </a:lvl9pPr>
           </a:lstStyle>
           <a:p>
             <a:pPr lvl="0"/>
             <a:r>
-              <a:rPr lang="en-US"/>
+              <a:rPr lang="en-US" smtClean="0"/>
               <a:t>Click to edit Master text styles</a:t>
             </a:r>
           </a:p>
@@ -2011,9 +1654,9 @@
           <a:bodyPr/>
           <a:lstStyle/>
           <a:p>
-            <a:fld id="{241EB5C9-1307-BA42-ABA2-0BC069CD8E7F}" type="datetimeFigureOut">
-              <a:rPr lang="en-US" smtClean="0"/>
-              <a:t>1/2/22</a:t>
+            <a:fld id="{5BCAD085-E8A6-8845-BD4E-CB4CCA059FC4}" type="datetimeFigureOut">
+              <a:rPr lang="en-US" smtClean="0"/>
+              <a:t>1/27/13</a:t>
             </a:fld>
             <a:endParaRPr lang="en-US"/>
           </a:p>
@@ -2053,7 +1696,7 @@
           <a:bodyPr/>
           <a:lstStyle/>
           <a:p>
-            <a:fld id="{C5EF2332-01BF-834F-8236-50238282D533}" type="slidenum">
+            <a:fld id="{C1FF6DA9-008F-8B48-92A6-B652298478BF}" type="slidenum">
               <a:rPr lang="en-US" smtClean="0"/>
               <a:t>‹#›</a:t>
             </a:fld>
@@ -2117,7 +1760,7 @@
     </p:spTree>
     <p:extLst>
       <p:ext uri="{BB962C8B-B14F-4D97-AF65-F5344CB8AC3E}">
-        <p14:creationId xmlns:p14="http://schemas.microsoft.com/office/powerpoint/2010/main" val="3540895647"/>
+        <p14:creationId xmlns:p14="http://schemas.microsoft.com/office/powerpoint/2010/main" val="1840726560"/>
       </p:ext>
     </p:extLst>
   </p:cSld>
@@ -2187,9 +1830,10 @@
           </a:lstStyle>
           <a:p>
             <a:r>
-              <a:rPr lang="en-US"/>
+              <a:rPr lang="en-US" smtClean="0"/>
               <a:t>Click to edit Master title style</a:t>
             </a:r>
+            <a:endParaRPr lang="en-US"/>
           </a:p>
         </p:txBody>
       </p:sp>
@@ -2214,39 +1858,39 @@
           <a:lstStyle>
             <a:lvl1pPr marL="0" indent="0">
               <a:buNone/>
+              <a:defRPr sz="3200"/>
+            </a:lvl1pPr>
+            <a:lvl2pPr marL="457200" indent="0">
+              <a:buNone/>
+              <a:defRPr sz="2800"/>
+            </a:lvl2pPr>
+            <a:lvl3pPr marL="914400" indent="0">
+              <a:buNone/>
               <a:defRPr sz="2400"/>
-            </a:lvl1pPr>
-            <a:lvl2pPr marL="342900" indent="0">
-              <a:buNone/>
-              <a:defRPr sz="2100"/>
-            </a:lvl2pPr>
-            <a:lvl3pPr marL="685800" indent="0">
-              <a:buNone/>
-              <a:defRPr sz="1800"/>
             </a:lvl3pPr>
-            <a:lvl4pPr marL="1028700" indent="0">
-              <a:buNone/>
-              <a:defRPr sz="1500"/>
+            <a:lvl4pPr marL="1371600" indent="0">
+              <a:buNone/>
+              <a:defRPr sz="2000"/>
             </a:lvl4pPr>
-            <a:lvl5pPr marL="1371600" indent="0">
-              <a:buNone/>
-              <a:defRPr sz="1500"/>
+            <a:lvl5pPr marL="1828800" indent="0">
+              <a:buNone/>
+              <a:defRPr sz="2000"/>
             </a:lvl5pPr>
-            <a:lvl6pPr marL="1714500" indent="0">
-              <a:buNone/>
-              <a:defRPr sz="1500"/>
+            <a:lvl6pPr marL="2286000" indent="0">
+              <a:buNone/>
+              <a:defRPr sz="2000"/>
             </a:lvl6pPr>
-            <a:lvl7pPr marL="2057400" indent="0">
-              <a:buNone/>
-              <a:defRPr sz="1500"/>
+            <a:lvl7pPr marL="2743200" indent="0">
+              <a:buNone/>
+              <a:defRPr sz="2000"/>
             </a:lvl7pPr>
-            <a:lvl8pPr marL="2400300" indent="0">
-              <a:buNone/>
-              <a:defRPr sz="1500"/>
+            <a:lvl8pPr marL="3200400" indent="0">
+              <a:buNone/>
+              <a:defRPr sz="2000"/>
             </a:lvl8pPr>
-            <a:lvl9pPr marL="2743200" indent="0">
-              <a:buNone/>
-              <a:defRPr sz="1500"/>
+            <a:lvl9pPr marL="3657600" indent="0">
+              <a:buNone/>
+              <a:defRPr sz="2000"/>
             </a:lvl9pPr>
           </a:lstStyle>
           <a:p>
@@ -2271,7 +1915,7 @@
           </a:xfrm>
         </p:spPr>
         <p:txBody>
-          <a:bodyPr/>
+          <a:bodyPr anchor="t"/>
           <a:lstStyle>
             <a:lvl1pPr marL="228600" indent="-228600">
               <a:spcAft>
@@ -2279,7 +1923,7 @@
               </a:spcAft>
               <a:buFont typeface="Arial"/>
               <a:buChar char="•"/>
-              <a:defRPr sz="1600">
+              <a:defRPr sz="1400">
                 <a:solidFill>
                   <a:srgbClr val="000000"/>
                 </a:solidFill>
@@ -2289,46 +1933,46 @@
             <a:lvl2pPr marL="685800" indent="-228600">
               <a:buFont typeface="Arial"/>
               <a:buChar char="•"/>
-              <a:defRPr sz="1400">
+              <a:defRPr sz="1200">
                 <a:solidFill>
                   <a:srgbClr val="000000"/>
                 </a:solidFill>
                 <a:latin typeface="Nunito"/>
               </a:defRPr>
             </a:lvl2pPr>
-            <a:lvl3pPr marL="685800" indent="0">
-              <a:buNone/>
-              <a:defRPr sz="750"/>
+            <a:lvl3pPr marL="914400" indent="0">
+              <a:buNone/>
+              <a:defRPr sz="1000"/>
             </a:lvl3pPr>
-            <a:lvl4pPr marL="1028700" indent="0">
-              <a:buNone/>
-              <a:defRPr sz="675"/>
+            <a:lvl4pPr marL="1371600" indent="0">
+              <a:buNone/>
+              <a:defRPr sz="900"/>
             </a:lvl4pPr>
-            <a:lvl5pPr marL="1371600" indent="0">
-              <a:buNone/>
-              <a:defRPr sz="675"/>
+            <a:lvl5pPr marL="1828800" indent="0">
+              <a:buNone/>
+              <a:defRPr sz="900"/>
             </a:lvl5pPr>
-            <a:lvl6pPr marL="1714500" indent="0">
-              <a:buNone/>
-              <a:defRPr sz="675"/>
+            <a:lvl6pPr marL="2286000" indent="0">
+              <a:buNone/>
+              <a:defRPr sz="900"/>
             </a:lvl6pPr>
-            <a:lvl7pPr marL="2057400" indent="0">
-              <a:buNone/>
-              <a:defRPr sz="675"/>
+            <a:lvl7pPr marL="2743200" indent="0">
+              <a:buNone/>
+              <a:defRPr sz="900"/>
             </a:lvl7pPr>
-            <a:lvl8pPr marL="2400300" indent="0">
-              <a:buNone/>
-              <a:defRPr sz="675"/>
+            <a:lvl8pPr marL="3200400" indent="0">
+              <a:buNone/>
+              <a:defRPr sz="900"/>
             </a:lvl8pPr>
-            <a:lvl9pPr marL="2743200" indent="0">
-              <a:buNone/>
-              <a:defRPr sz="675"/>
+            <a:lvl9pPr marL="3657600" indent="0">
+              <a:buNone/>
+              <a:defRPr sz="900"/>
             </a:lvl9pPr>
           </a:lstStyle>
           <a:p>
             <a:pPr lvl="0"/>
             <a:r>
-              <a:rPr lang="en-US"/>
+              <a:rPr lang="en-US" smtClean="0"/>
               <a:t>Click to edit Master text styles</a:t>
             </a:r>
           </a:p>
@@ -2349,9 +1993,9 @@
           <a:bodyPr/>
           <a:lstStyle/>
           <a:p>
-            <a:fld id="{241EB5C9-1307-BA42-ABA2-0BC069CD8E7F}" type="datetimeFigureOut">
-              <a:rPr lang="en-US" smtClean="0"/>
-              <a:t>1/2/22</a:t>
+            <a:fld id="{5BCAD085-E8A6-8845-BD4E-CB4CCA059FC4}" type="datetimeFigureOut">
+              <a:rPr lang="en-US" smtClean="0"/>
+              <a:t>1/27/13</a:t>
             </a:fld>
             <a:endParaRPr lang="en-US"/>
           </a:p>
@@ -2391,7 +2035,7 @@
           <a:bodyPr/>
           <a:lstStyle/>
           <a:p>
-            <a:fld id="{C5EF2332-01BF-834F-8236-50238282D533}" type="slidenum">
+            <a:fld id="{C1FF6DA9-008F-8B48-92A6-B652298478BF}" type="slidenum">
               <a:rPr lang="en-US" smtClean="0"/>
               <a:t>‹#›</a:t>
             </a:fld>
@@ -2431,7 +2075,7 @@
     </p:spTree>
     <p:extLst>
       <p:ext uri="{BB962C8B-B14F-4D97-AF65-F5344CB8AC3E}">
-        <p14:creationId xmlns:p14="http://schemas.microsoft.com/office/powerpoint/2010/main" val="3566899855"/>
+        <p14:creationId xmlns:p14="http://schemas.microsoft.com/office/powerpoint/2010/main" val="3889236939"/>
       </p:ext>
     </p:extLst>
   </p:cSld>
@@ -2475,8 +2119,8 @@
         </p:nvSpPr>
         <p:spPr>
           <a:xfrm>
-            <a:off x="457200" y="205979"/>
-            <a:ext cx="8229600" cy="857250"/>
+            <a:off x="457200" y="274638"/>
+            <a:ext cx="8229600" cy="1143000"/>
           </a:xfrm>
           <a:prstGeom prst="rect">
             <a:avLst/>
@@ -2489,9 +2133,10 @@
           <a:lstStyle/>
           <a:p>
             <a:r>
-              <a:rPr lang="en-US"/>
+              <a:rPr lang="en-US" smtClean="0"/>
               <a:t>Click to edit Master title style</a:t>
             </a:r>
+            <a:endParaRPr lang="en-US"/>
           </a:p>
         </p:txBody>
       </p:sp>
@@ -2507,8 +2152,8 @@
         </p:nvSpPr>
         <p:spPr>
           <a:xfrm>
-            <a:off x="457200" y="1200151"/>
-            <a:ext cx="8229600" cy="3394472"/>
+            <a:off x="457200" y="1600200"/>
+            <a:ext cx="8229600" cy="4525963"/>
           </a:xfrm>
           <a:prstGeom prst="rect">
             <a:avLst/>
@@ -2522,37 +2167,38 @@
           <a:p>
             <a:pPr lvl="0"/>
             <a:r>
-              <a:rPr lang="en-US"/>
+              <a:rPr lang="en-US" smtClean="0"/>
               <a:t>Click to edit Master text styles</a:t>
             </a:r>
           </a:p>
           <a:p>
             <a:pPr lvl="1"/>
             <a:r>
-              <a:rPr lang="en-US"/>
+              <a:rPr lang="en-US" smtClean="0"/>
               <a:t>Second level</a:t>
             </a:r>
           </a:p>
           <a:p>
             <a:pPr lvl="2"/>
             <a:r>
-              <a:rPr lang="en-US"/>
+              <a:rPr lang="en-US" smtClean="0"/>
               <a:t>Third level</a:t>
             </a:r>
           </a:p>
           <a:p>
             <a:pPr lvl="3"/>
             <a:r>
-              <a:rPr lang="en-US"/>
+              <a:rPr lang="en-US" smtClean="0"/>
               <a:t>Fourth level</a:t>
             </a:r>
           </a:p>
           <a:p>
             <a:pPr lvl="4"/>
             <a:r>
-              <a:rPr lang="en-US"/>
+              <a:rPr lang="en-US" smtClean="0"/>
               <a:t>Fifth level</a:t>
             </a:r>
+            <a:endParaRPr lang="en-US"/>
           </a:p>
         </p:txBody>
       </p:sp>
@@ -2568,8 +2214,8 @@
         </p:nvSpPr>
         <p:spPr>
           <a:xfrm>
-            <a:off x="457200" y="4767263"/>
-            <a:ext cx="2133600" cy="273844"/>
+            <a:off x="457200" y="6356350"/>
+            <a:ext cx="2133600" cy="365125"/>
           </a:xfrm>
           <a:prstGeom prst="rect">
             <a:avLst/>
@@ -2579,7 +2225,7 @@
           <a:bodyPr vert="horz" lIns="91440" tIns="45720" rIns="91440" bIns="45720" rtlCol="0" anchor="ctr"/>
           <a:lstStyle>
             <a:lvl1pPr algn="l">
-              <a:defRPr sz="900">
+              <a:defRPr sz="1200">
                 <a:solidFill>
                   <a:schemeClr val="tx1">
                     <a:tint val="75000"/>
@@ -2589,9 +2235,9 @@
             </a:lvl1pPr>
           </a:lstStyle>
           <a:p>
-            <a:fld id="{241EB5C9-1307-BA42-ABA2-0BC069CD8E7F}" type="datetimeFigureOut">
-              <a:rPr lang="en-US" smtClean="0"/>
-              <a:t>1/2/22</a:t>
+            <a:fld id="{5BCAD085-E8A6-8845-BD4E-CB4CCA059FC4}" type="datetimeFigureOut">
+              <a:rPr lang="en-US" smtClean="0"/>
+              <a:t>1/27/13</a:t>
             </a:fld>
             <a:endParaRPr lang="en-US"/>
           </a:p>
@@ -2609,8 +2255,8 @@
         </p:nvSpPr>
         <p:spPr>
           <a:xfrm>
-            <a:off x="3124200" y="4767263"/>
-            <a:ext cx="2895600" cy="273844"/>
+            <a:off x="3124200" y="6356350"/>
+            <a:ext cx="2895600" cy="365125"/>
           </a:xfrm>
           <a:prstGeom prst="rect">
             <a:avLst/>
@@ -2620,7 +2266,7 @@
           <a:bodyPr vert="horz" lIns="91440" tIns="45720" rIns="91440" bIns="45720" rtlCol="0" anchor="ctr"/>
           <a:lstStyle>
             <a:lvl1pPr algn="ctr">
-              <a:defRPr sz="900">
+              <a:defRPr sz="1200">
                 <a:solidFill>
                   <a:schemeClr val="tx1">
                     <a:tint val="75000"/>
@@ -2646,8 +2292,8 @@
         </p:nvSpPr>
         <p:spPr>
           <a:xfrm>
-            <a:off x="6553200" y="4767263"/>
-            <a:ext cx="2133600" cy="273844"/>
+            <a:off x="6553200" y="6356350"/>
+            <a:ext cx="2133600" cy="365125"/>
           </a:xfrm>
           <a:prstGeom prst="rect">
             <a:avLst/>
@@ -2657,7 +2303,7 @@
           <a:bodyPr vert="horz" lIns="91440" tIns="45720" rIns="91440" bIns="45720" rtlCol="0" anchor="ctr"/>
           <a:lstStyle>
             <a:lvl1pPr algn="r">
-              <a:defRPr sz="900">
+              <a:defRPr sz="1200">
                 <a:solidFill>
                   <a:schemeClr val="tx1">
                     <a:tint val="75000"/>
@@ -2667,7 +2313,7 @@
             </a:lvl1pPr>
           </a:lstStyle>
           <a:p>
-            <a:fld id="{C5EF2332-01BF-834F-8236-50238282D533}" type="slidenum">
+            <a:fld id="{C1FF6DA9-008F-8B48-92A6-B652298478BF}" type="slidenum">
               <a:rPr lang="en-US" smtClean="0"/>
               <a:t>‹#›</a:t>
             </a:fld>
@@ -2702,7 +2348,7 @@
     </p:spTree>
     <p:extLst>
       <p:ext uri="{BB962C8B-B14F-4D97-AF65-F5344CB8AC3E}">
-        <p14:creationId xmlns:p14="http://schemas.microsoft.com/office/powerpoint/2010/main" val="3676200875"/>
+        <p14:creationId xmlns:p14="http://schemas.microsoft.com/office/powerpoint/2010/main" val="2209977519"/>
       </p:ext>
     </p:extLst>
   </p:cSld>
@@ -2718,12 +2364,12 @@
   </p:sldLayoutIdLst>
   <p:txStyles>
     <p:titleStyle>
-      <a:lvl1pPr algn="ctr" defTabSz="342900" rtl="0" eaLnBrk="1" latinLnBrk="0" hangingPunct="1">
+      <a:lvl1pPr algn="ctr" defTabSz="457200" rtl="0" eaLnBrk="1" latinLnBrk="0" hangingPunct="1">
         <a:spcBef>
           <a:spcPct val="0"/>
         </a:spcBef>
         <a:buNone/>
-        <a:defRPr sz="3300" kern="1200">
+        <a:defRPr sz="4400" kern="1200">
           <a:solidFill>
             <a:schemeClr val="tx1"/>
           </a:solidFill>
@@ -2734,7 +2380,37 @@
       </a:lvl1pPr>
     </p:titleStyle>
     <p:bodyStyle>
-      <a:lvl1pPr marL="342900" indent="-342900" algn="l" defTabSz="342900" rtl="0" eaLnBrk="1" latinLnBrk="0" hangingPunct="1">
+      <a:lvl1pPr marL="342900" indent="-342900" algn="l" defTabSz="457200" rtl="0" eaLnBrk="1" latinLnBrk="0" hangingPunct="1">
+        <a:spcBef>
+          <a:spcPct val="20000"/>
+        </a:spcBef>
+        <a:buFont typeface="Arial"/>
+        <a:buChar char="•"/>
+        <a:defRPr sz="3200" kern="1200">
+          <a:solidFill>
+            <a:schemeClr val="tx1"/>
+          </a:solidFill>
+          <a:latin typeface="+mn-lt"/>
+          <a:ea typeface="+mn-ea"/>
+          <a:cs typeface="+mn-cs"/>
+        </a:defRPr>
+      </a:lvl1pPr>
+      <a:lvl2pPr marL="742950" indent="-285750" algn="l" defTabSz="457200" rtl="0" eaLnBrk="1" latinLnBrk="0" hangingPunct="1">
+        <a:spcBef>
+          <a:spcPct val="20000"/>
+        </a:spcBef>
+        <a:buFont typeface="Arial"/>
+        <a:buChar char="–"/>
+        <a:defRPr sz="2800" kern="1200">
+          <a:solidFill>
+            <a:schemeClr val="tx1"/>
+          </a:solidFill>
+          <a:latin typeface="+mn-lt"/>
+          <a:ea typeface="+mn-ea"/>
+          <a:cs typeface="+mn-cs"/>
+        </a:defRPr>
+      </a:lvl2pPr>
+      <a:lvl3pPr marL="1143000" indent="-228600" algn="l" defTabSz="457200" rtl="0" eaLnBrk="1" latinLnBrk="0" hangingPunct="1">
         <a:spcBef>
           <a:spcPct val="20000"/>
         </a:spcBef>
@@ -2748,44 +2424,14 @@
           <a:ea typeface="+mn-ea"/>
           <a:cs typeface="+mn-cs"/>
         </a:defRPr>
-      </a:lvl1pPr>
-      <a:lvl2pPr marL="685800" indent="-342900" algn="l" defTabSz="342900" rtl="0" eaLnBrk="1" latinLnBrk="0" hangingPunct="1">
+      </a:lvl3pPr>
+      <a:lvl4pPr marL="1600200" indent="-228600" algn="l" defTabSz="457200" rtl="0" eaLnBrk="1" latinLnBrk="0" hangingPunct="1">
         <a:spcBef>
           <a:spcPct val="20000"/>
         </a:spcBef>
         <a:buFont typeface="Arial"/>
         <a:buChar char="–"/>
-        <a:defRPr sz="2100" kern="1200">
-          <a:solidFill>
-            <a:schemeClr val="tx1"/>
-          </a:solidFill>
-          <a:latin typeface="+mn-lt"/>
-          <a:ea typeface="+mn-ea"/>
-          <a:cs typeface="+mn-cs"/>
-        </a:defRPr>
-      </a:lvl2pPr>
-      <a:lvl3pPr marL="1028700" indent="-342900" algn="l" defTabSz="342900" rtl="0" eaLnBrk="1" latinLnBrk="0" hangingPunct="1">
-        <a:spcBef>
-          <a:spcPct val="20000"/>
-        </a:spcBef>
-        <a:buFont typeface="Arial"/>
-        <a:buChar char="•"/>
-        <a:defRPr sz="1800" kern="1200">
-          <a:solidFill>
-            <a:schemeClr val="tx1"/>
-          </a:solidFill>
-          <a:latin typeface="+mn-lt"/>
-          <a:ea typeface="+mn-ea"/>
-          <a:cs typeface="+mn-cs"/>
-        </a:defRPr>
-      </a:lvl3pPr>
-      <a:lvl4pPr marL="1371600" indent="-342900" algn="l" defTabSz="342900" rtl="0" eaLnBrk="1" latinLnBrk="0" hangingPunct="1">
-        <a:spcBef>
-          <a:spcPct val="20000"/>
-        </a:spcBef>
-        <a:buFont typeface="Arial"/>
-        <a:buChar char="–"/>
-        <a:defRPr sz="1500" kern="1200">
+        <a:defRPr sz="2000" kern="1200">
           <a:solidFill>
             <a:schemeClr val="tx1"/>
           </a:solidFill>
@@ -2794,13 +2440,13 @@
           <a:cs typeface="+mn-cs"/>
         </a:defRPr>
       </a:lvl4pPr>
-      <a:lvl5pPr marL="1714500" indent="-342900" algn="l" defTabSz="342900" rtl="0" eaLnBrk="1" latinLnBrk="0" hangingPunct="1">
+      <a:lvl5pPr marL="2057400" indent="-228600" algn="l" defTabSz="457200" rtl="0" eaLnBrk="1" latinLnBrk="0" hangingPunct="1">
         <a:spcBef>
           <a:spcPct val="20000"/>
         </a:spcBef>
         <a:buFont typeface="Arial"/>
         <a:buChar char="»"/>
-        <a:defRPr sz="1500" kern="1200">
+        <a:defRPr sz="2000" kern="1200">
           <a:solidFill>
             <a:schemeClr val="tx1"/>
           </a:solidFill>
@@ -2809,13 +2455,13 @@
           <a:cs typeface="+mn-cs"/>
         </a:defRPr>
       </a:lvl5pPr>
-      <a:lvl6pPr marL="2057400" indent="-342900" algn="l" defTabSz="342900" rtl="0" eaLnBrk="1" latinLnBrk="0" hangingPunct="1">
+      <a:lvl6pPr marL="2514600" indent="-228600" algn="l" defTabSz="457200" rtl="0" eaLnBrk="1" latinLnBrk="0" hangingPunct="1">
         <a:spcBef>
           <a:spcPct val="20000"/>
         </a:spcBef>
         <a:buFont typeface="Arial"/>
         <a:buChar char="•"/>
-        <a:defRPr sz="1500" kern="1200">
+        <a:defRPr sz="2000" kern="1200">
           <a:solidFill>
             <a:schemeClr val="tx1"/>
           </a:solidFill>
@@ -2824,13 +2470,13 @@
           <a:cs typeface="+mn-cs"/>
         </a:defRPr>
       </a:lvl6pPr>
-      <a:lvl7pPr marL="2400300" indent="-342900" algn="l" defTabSz="342900" rtl="0" eaLnBrk="1" latinLnBrk="0" hangingPunct="1">
+      <a:lvl7pPr marL="2971800" indent="-228600" algn="l" defTabSz="457200" rtl="0" eaLnBrk="1" latinLnBrk="0" hangingPunct="1">
         <a:spcBef>
           <a:spcPct val="20000"/>
         </a:spcBef>
         <a:buFont typeface="Arial"/>
         <a:buChar char="•"/>
-        <a:defRPr sz="1500" kern="1200">
+        <a:defRPr sz="2000" kern="1200">
           <a:solidFill>
             <a:schemeClr val="tx1"/>
           </a:solidFill>
@@ -2839,13 +2485,13 @@
           <a:cs typeface="+mn-cs"/>
         </a:defRPr>
       </a:lvl7pPr>
-      <a:lvl8pPr marL="2743200" indent="-342900" algn="l" defTabSz="342900" rtl="0" eaLnBrk="1" latinLnBrk="0" hangingPunct="1">
+      <a:lvl8pPr marL="3429000" indent="-228600" algn="l" defTabSz="457200" rtl="0" eaLnBrk="1" latinLnBrk="0" hangingPunct="1">
         <a:spcBef>
           <a:spcPct val="20000"/>
         </a:spcBef>
         <a:buFont typeface="Arial"/>
         <a:buChar char="•"/>
-        <a:defRPr sz="1500" kern="1200">
+        <a:defRPr sz="2000" kern="1200">
           <a:solidFill>
             <a:schemeClr val="tx1"/>
           </a:solidFill>
@@ -2854,13 +2500,13 @@
           <a:cs typeface="+mn-cs"/>
         </a:defRPr>
       </a:lvl8pPr>
-      <a:lvl9pPr marL="3086100" indent="-342900" algn="l" defTabSz="342900" rtl="0" eaLnBrk="1" latinLnBrk="0" hangingPunct="1">
+      <a:lvl9pPr marL="3886200" indent="-228600" algn="l" defTabSz="457200" rtl="0" eaLnBrk="1" latinLnBrk="0" hangingPunct="1">
         <a:spcBef>
           <a:spcPct val="20000"/>
         </a:spcBef>
         <a:buFont typeface="Arial"/>
         <a:buChar char="•"/>
-        <a:defRPr sz="1500" kern="1200">
+        <a:defRPr sz="2000" kern="1200">
           <a:solidFill>
             <a:schemeClr val="tx1"/>
           </a:solidFill>
@@ -2874,8 +2520,8 @@
       <a:defPPr>
         <a:defRPr lang="en-US"/>
       </a:defPPr>
-      <a:lvl1pPr marL="0" algn="l" defTabSz="342900" rtl="0" eaLnBrk="1" latinLnBrk="0" hangingPunct="1">
-        <a:defRPr sz="1350" kern="1200">
+      <a:lvl1pPr marL="0" algn="l" defTabSz="457200" rtl="0" eaLnBrk="1" latinLnBrk="0" hangingPunct="1">
+        <a:defRPr sz="1800" kern="1200">
           <a:solidFill>
             <a:schemeClr val="tx1"/>
           </a:solidFill>
@@ -2884,8 +2530,8 @@
           <a:cs typeface="+mn-cs"/>
         </a:defRPr>
       </a:lvl1pPr>
-      <a:lvl2pPr marL="342900" algn="l" defTabSz="342900" rtl="0" eaLnBrk="1" latinLnBrk="0" hangingPunct="1">
-        <a:defRPr sz="1350" kern="1200">
+      <a:lvl2pPr marL="457200" algn="l" defTabSz="457200" rtl="0" eaLnBrk="1" latinLnBrk="0" hangingPunct="1">
+        <a:defRPr sz="1800" kern="1200">
           <a:solidFill>
             <a:schemeClr val="tx1"/>
           </a:solidFill>
@@ -2894,8 +2540,8 @@
           <a:cs typeface="+mn-cs"/>
         </a:defRPr>
       </a:lvl2pPr>
-      <a:lvl3pPr marL="685800" algn="l" defTabSz="342900" rtl="0" eaLnBrk="1" latinLnBrk="0" hangingPunct="1">
-        <a:defRPr sz="1350" kern="1200">
+      <a:lvl3pPr marL="914400" algn="l" defTabSz="457200" rtl="0" eaLnBrk="1" latinLnBrk="0" hangingPunct="1">
+        <a:defRPr sz="1800" kern="1200">
           <a:solidFill>
             <a:schemeClr val="tx1"/>
           </a:solidFill>
@@ -2904,8 +2550,8 @@
           <a:cs typeface="+mn-cs"/>
         </a:defRPr>
       </a:lvl3pPr>
-      <a:lvl4pPr marL="1028700" algn="l" defTabSz="342900" rtl="0" eaLnBrk="1" latinLnBrk="0" hangingPunct="1">
-        <a:defRPr sz="1350" kern="1200">
+      <a:lvl4pPr marL="1371600" algn="l" defTabSz="457200" rtl="0" eaLnBrk="1" latinLnBrk="0" hangingPunct="1">
+        <a:defRPr sz="1800" kern="1200">
           <a:solidFill>
             <a:schemeClr val="tx1"/>
           </a:solidFill>
@@ -2914,8 +2560,8 @@
           <a:cs typeface="+mn-cs"/>
         </a:defRPr>
       </a:lvl4pPr>
-      <a:lvl5pPr marL="1371600" algn="l" defTabSz="342900" rtl="0" eaLnBrk="1" latinLnBrk="0" hangingPunct="1">
-        <a:defRPr sz="1350" kern="1200">
+      <a:lvl5pPr marL="1828800" algn="l" defTabSz="457200" rtl="0" eaLnBrk="1" latinLnBrk="0" hangingPunct="1">
+        <a:defRPr sz="1800" kern="1200">
           <a:solidFill>
             <a:schemeClr val="tx1"/>
           </a:solidFill>
@@ -2924,8 +2570,8 @@
           <a:cs typeface="+mn-cs"/>
         </a:defRPr>
       </a:lvl5pPr>
-      <a:lvl6pPr marL="1714500" algn="l" defTabSz="342900" rtl="0" eaLnBrk="1" latinLnBrk="0" hangingPunct="1">
-        <a:defRPr sz="1350" kern="1200">
+      <a:lvl6pPr marL="2286000" algn="l" defTabSz="457200" rtl="0" eaLnBrk="1" latinLnBrk="0" hangingPunct="1">
+        <a:defRPr sz="1800" kern="1200">
           <a:solidFill>
             <a:schemeClr val="tx1"/>
           </a:solidFill>
@@ -2934,8 +2580,8 @@
           <a:cs typeface="+mn-cs"/>
         </a:defRPr>
       </a:lvl6pPr>
-      <a:lvl7pPr marL="2057400" algn="l" defTabSz="342900" rtl="0" eaLnBrk="1" latinLnBrk="0" hangingPunct="1">
-        <a:defRPr sz="1350" kern="1200">
+      <a:lvl7pPr marL="2743200" algn="l" defTabSz="457200" rtl="0" eaLnBrk="1" latinLnBrk="0" hangingPunct="1">
+        <a:defRPr sz="1800" kern="1200">
           <a:solidFill>
             <a:schemeClr val="tx1"/>
           </a:solidFill>
@@ -2944,8 +2590,8 @@
           <a:cs typeface="+mn-cs"/>
         </a:defRPr>
       </a:lvl7pPr>
-      <a:lvl8pPr marL="2400300" algn="l" defTabSz="342900" rtl="0" eaLnBrk="1" latinLnBrk="0" hangingPunct="1">
-        <a:defRPr sz="1350" kern="1200">
+      <a:lvl8pPr marL="3200400" algn="l" defTabSz="457200" rtl="0" eaLnBrk="1" latinLnBrk="0" hangingPunct="1">
+        <a:defRPr sz="1800" kern="1200">
           <a:solidFill>
             <a:schemeClr val="tx1"/>
           </a:solidFill>
@@ -2954,8 +2600,8 @@
           <a:cs typeface="+mn-cs"/>
         </a:defRPr>
       </a:lvl8pPr>
-      <a:lvl9pPr marL="2743200" algn="l" defTabSz="342900" rtl="0" eaLnBrk="1" latinLnBrk="0" hangingPunct="1">
-        <a:defRPr sz="1350" kern="1200">
+      <a:lvl9pPr marL="3657600" algn="l" defTabSz="457200" rtl="0" eaLnBrk="1" latinLnBrk="0" hangingPunct="1">
+        <a:defRPr sz="1800" kern="1200">
           <a:solidFill>
             <a:schemeClr val="tx1"/>
           </a:solidFill>
@@ -3287,265 +2933,4 @@
   </a:objectDefaults>
   <a:extraClrSchemeLst/>
 </a:theme>
-</file>
-
-<file path=ppt/theme/theme2.xml><?xml version="1.0" encoding="utf-8"?>
-<a:theme xmlns:a="http://schemas.openxmlformats.org/drawingml/2006/main" name="Office Theme">
-  <a:themeElements>
-    <a:clrScheme name="Office">
-      <a:dk1>
-        <a:sysClr val="windowText" lastClr="000000"/>
-      </a:dk1>
-      <a:lt1>
-        <a:sysClr val="window" lastClr="FFFFFF"/>
-      </a:lt1>
-      <a:dk2>
-        <a:srgbClr val="44546A"/>
-      </a:dk2>
-      <a:lt2>
-        <a:srgbClr val="E7E6E6"/>
-      </a:lt2>
-      <a:accent1>
-        <a:srgbClr val="5B9BD5"/>
-      </a:accent1>
-      <a:accent2>
-        <a:srgbClr val="ED7D31"/>
-      </a:accent2>
-      <a:accent3>
-        <a:srgbClr val="A5A5A5"/>
-      </a:accent3>
-      <a:accent4>
-        <a:srgbClr val="FFC000"/>
-      </a:accent4>
-      <a:accent5>
-        <a:srgbClr val="4472C4"/>
-      </a:accent5>
-      <a:accent6>
-        <a:srgbClr val="70AD47"/>
-      </a:accent6>
-      <a:hlink>
-        <a:srgbClr val="0563C1"/>
-      </a:hlink>
-      <a:folHlink>
-        <a:srgbClr val="954F72"/>
-      </a:folHlink>
-    </a:clrScheme>
-    <a:fontScheme name="Office">
-      <a:majorFont>
-        <a:latin typeface="Calibri Light" panose="020F0302020204030204"/>
-        <a:ea typeface=""/>
-        <a:cs typeface=""/>
-        <a:font script="Jpan" typeface="ＭＳ Ｐゴシック"/>
-        <a:font script="Hang" typeface="맑은 고딕"/>
-        <a:font script="Hans" typeface="宋体"/>
-        <a:font script="Hant" typeface="新細明體"/>
-        <a:font script="Arab" typeface="Times New Roman"/>
-        <a:font script="Hebr" typeface="Times New Roman"/>
-        <a:font script="Thai" typeface="Angsana New"/>
-        <a:font script="Ethi" typeface="Nyala"/>
-        <a:font script="Beng" typeface="Vrinda"/>
-        <a:font script="Gujr" typeface="Shruti"/>
-        <a:font script="Khmr" typeface="MoolBoran"/>
-        <a:font script="Knda" typeface="Tunga"/>
-        <a:font script="Guru" typeface="Raavi"/>
-        <a:font script="Cans" typeface="Euphemia"/>
-        <a:font script="Cher" typeface="Plantagenet Cherokee"/>
-        <a:font script="Yiii" typeface="Microsoft Yi Baiti"/>
-        <a:font script="Tibt" typeface="Microsoft Himalaya"/>
-        <a:font script="Thaa" typeface="MV Boli"/>
-        <a:font script="Deva" typeface="Mangal"/>
-        <a:font script="Telu" typeface="Gautami"/>
-        <a:font script="Taml" typeface="Latha"/>
-        <a:font script="Syrc" typeface="Estrangelo Edessa"/>
-        <a:font script="Orya" typeface="Kalinga"/>
-        <a:font script="Mlym" typeface="Kartika"/>
-        <a:font script="Laoo" typeface="DokChampa"/>
-        <a:font script="Sinh" typeface="Iskoola Pota"/>
-        <a:font script="Mong" typeface="Mongolian Baiti"/>
-        <a:font script="Viet" typeface="Times New Roman"/>
-        <a:font script="Uigh" typeface="Microsoft Uighur"/>
-        <a:font script="Geor" typeface="Sylfaen"/>
-      </a:majorFont>
-      <a:minorFont>
-        <a:latin typeface="Calibri" panose="020F0502020204030204"/>
-        <a:ea typeface=""/>
-        <a:cs typeface=""/>
-        <a:font script="Jpan" typeface="ＭＳ Ｐゴシック"/>
-        <a:font script="Hang" typeface="맑은 고딕"/>
-        <a:font script="Hans" typeface="宋体"/>
-        <a:font script="Hant" typeface="新細明體"/>
-        <a:font script="Arab" typeface="Arial"/>
-        <a:font script="Hebr" typeface="Arial"/>
-        <a:font script="Thai" typeface="Cordia New"/>
-        <a:font script="Ethi" typeface="Nyala"/>
-        <a:font script="Beng" typeface="Vrinda"/>
-        <a:font script="Gujr" typeface="Shruti"/>
-        <a:font script="Khmr" typeface="DaunPenh"/>
-        <a:font script="Knda" typeface="Tunga"/>
-        <a:font script="Guru" typeface="Raavi"/>
-        <a:font script="Cans" typeface="Euphemia"/>
-        <a:font script="Cher" typeface="Plantagenet Cherokee"/>
-        <a:font script="Yiii" typeface="Microsoft Yi Baiti"/>
-        <a:font script="Tibt" typeface="Microsoft Himalaya"/>
-        <a:font script="Thaa" typeface="MV Boli"/>
-        <a:font script="Deva" typeface="Mangal"/>
-        <a:font script="Telu" typeface="Gautami"/>
-        <a:font script="Taml" typeface="Latha"/>
-        <a:font script="Syrc" typeface="Estrangelo Edessa"/>
-        <a:font script="Orya" typeface="Kalinga"/>
-        <a:font script="Mlym" typeface="Kartika"/>
-        <a:font script="Laoo" typeface="DokChampa"/>
-        <a:font script="Sinh" typeface="Iskoola Pota"/>
-        <a:font script="Mong" typeface="Mongolian Baiti"/>
-        <a:font script="Viet" typeface="Arial"/>
-        <a:font script="Uigh" typeface="Microsoft Uighur"/>
-        <a:font script="Geor" typeface="Sylfaen"/>
-      </a:minorFont>
-    </a:fontScheme>
-    <a:fmtScheme name="Office">
-      <a:fillStyleLst>
-        <a:solidFill>
-          <a:schemeClr val="phClr"/>
-        </a:solidFill>
-        <a:gradFill rotWithShape="1">
-          <a:gsLst>
-            <a:gs pos="0">
-              <a:schemeClr val="phClr">
-                <a:lumMod val="110000"/>
-                <a:satMod val="105000"/>
-                <a:tint val="67000"/>
-              </a:schemeClr>
-            </a:gs>
-            <a:gs pos="50000">
-              <a:schemeClr val="phClr">
-                <a:lumMod val="105000"/>
-                <a:satMod val="103000"/>
-                <a:tint val="73000"/>
-              </a:schemeClr>
-            </a:gs>
-            <a:gs pos="100000">
-              <a:schemeClr val="phClr">
-                <a:lumMod val="105000"/>
-                <a:satMod val="109000"/>
-                <a:tint val="81000"/>
-              </a:schemeClr>
-            </a:gs>
-          </a:gsLst>
-          <a:lin ang="5400000" scaled="0"/>
-        </a:gradFill>
-        <a:gradFill rotWithShape="1">
-          <a:gsLst>
-            <a:gs pos="0">
-              <a:schemeClr val="phClr">
-                <a:satMod val="103000"/>
-                <a:lumMod val="102000"/>
-                <a:tint val="94000"/>
-              </a:schemeClr>
-            </a:gs>
-            <a:gs pos="50000">
-              <a:schemeClr val="phClr">
-                <a:satMod val="110000"/>
-                <a:lumMod val="100000"/>
-                <a:shade val="100000"/>
-              </a:schemeClr>
-            </a:gs>
-            <a:gs pos="100000">
-              <a:schemeClr val="phClr">
-                <a:lumMod val="99000"/>
-                <a:satMod val="120000"/>
-                <a:shade val="78000"/>
-              </a:schemeClr>
-            </a:gs>
-          </a:gsLst>
-          <a:lin ang="5400000" scaled="0"/>
-        </a:gradFill>
-      </a:fillStyleLst>
-      <a:lnStyleLst>
-        <a:ln w="6350" cap="flat" cmpd="sng" algn="ctr">
-          <a:solidFill>
-            <a:schemeClr val="phClr"/>
-          </a:solidFill>
-          <a:prstDash val="solid"/>
-          <a:miter lim="800000"/>
-        </a:ln>
-        <a:ln w="12700" cap="flat" cmpd="sng" algn="ctr">
-          <a:solidFill>
-            <a:schemeClr val="phClr"/>
-          </a:solidFill>
-          <a:prstDash val="solid"/>
-          <a:miter lim="800000"/>
-        </a:ln>
-        <a:ln w="19050" cap="flat" cmpd="sng" algn="ctr">
-          <a:solidFill>
-            <a:schemeClr val="phClr"/>
-          </a:solidFill>
-          <a:prstDash val="solid"/>
-          <a:miter lim="800000"/>
-        </a:ln>
-      </a:lnStyleLst>
-      <a:effectStyleLst>
-        <a:effectStyle>
-          <a:effectLst/>
-        </a:effectStyle>
-        <a:effectStyle>
-          <a:effectLst/>
-        </a:effectStyle>
-        <a:effectStyle>
-          <a:effectLst>
-            <a:outerShdw blurRad="57150" dist="19050" dir="5400000" algn="ctr" rotWithShape="0">
-              <a:srgbClr val="000000">
-                <a:alpha val="63000"/>
-              </a:srgbClr>
-            </a:outerShdw>
-          </a:effectLst>
-        </a:effectStyle>
-      </a:effectStyleLst>
-      <a:bgFillStyleLst>
-        <a:solidFill>
-          <a:schemeClr val="phClr"/>
-        </a:solidFill>
-        <a:solidFill>
-          <a:schemeClr val="phClr">
-            <a:tint val="95000"/>
-            <a:satMod val="170000"/>
-          </a:schemeClr>
-        </a:solidFill>
-        <a:gradFill rotWithShape="1">
-          <a:gsLst>
-            <a:gs pos="0">
-              <a:schemeClr val="phClr">
-                <a:tint val="93000"/>
-                <a:satMod val="150000"/>
-                <a:shade val="98000"/>
-                <a:lumMod val="102000"/>
-              </a:schemeClr>
-            </a:gs>
-            <a:gs pos="50000">
-              <a:schemeClr val="phClr">
-                <a:tint val="98000"/>
-                <a:satMod val="130000"/>
-                <a:shade val="90000"/>
-                <a:lumMod val="103000"/>
-              </a:schemeClr>
-            </a:gs>
-            <a:gs pos="100000">
-              <a:schemeClr val="phClr">
-                <a:shade val="63000"/>
-                <a:satMod val="120000"/>
-              </a:schemeClr>
-            </a:gs>
-          </a:gsLst>
-          <a:lin ang="5400000" scaled="0"/>
-        </a:gradFill>
-      </a:bgFillStyleLst>
-    </a:fmtScheme>
-  </a:themeElements>
-  <a:objectDefaults/>
-  <a:extraClrSchemeLst/>
-  <a:extLst>
-    <a:ext uri="{05A4C25C-085E-4340-85A3-A5531E510DB2}">
-      <thm15:themeFamily xmlns:thm15="http://schemas.microsoft.com/office/thememl/2012/main" name="Office Theme" id="{62F939B6-93AF-4DB8-9C6B-D6C7DFDC589F}" vid="{4A3C46E8-61CC-4603-A589-7422A47A8E4A}"/>
-    </a:ext>
-  </a:extLst>
-</a:theme>
 </file>
</xml_diff>